<commit_message>
Refine TalkTrack layout and output defaults
</commit_message>
<xml_diff>
--- a/assets/shunyejiang-template.pptx
+++ b/assets/shunyejiang-template.pptx
@@ -3685,7 +3685,7 @@
         </p:nvSpPr>
         <p:spPr>
           <a:xfrm>
-            <a:off x="4142105" y="3122930"/>
+            <a:off x="4005897" y="2927985"/>
             <a:ext cx="9370695" cy="1839595"/>
           </a:xfrm>
           <a:prstGeom prst="rect">
@@ -3694,7 +3694,7 @@
           <a:noFill/>
         </p:spPr>
         <p:txBody>
-          <a:bodyPr wrap="square" lIns="73152" tIns="73152" rIns="73152" bIns="73152" anchor="t">
+          <a:bodyPr wrap="square" lIns="73152" tIns="73152" rIns="73152" bIns="73152" anchor="ctr">
             <a:noAutofit/>
           </a:bodyPr>
           <a:lstStyle/>

</xml_diff>